<commit_message>
docs: Update presentation with QR code
</commit_message>
<xml_diff>
--- a/Predictive_Maintenance_Presentation.pptx
+++ b/Predictive_Maintenance_Presentation.pptx
@@ -148,7 +148,7 @@
   <pc:docChgLst>
     <pc:chgData name="محمد رضا مصطفى علي" userId="c6ea1ee86786e35d" providerId="LiveId" clId="{471EB1E5-A5B5-4169-BAFF-97E1977EEA39}"/>
     <pc:docChg chg="undo custSel modSld">
-      <pc:chgData name="محمد رضا مصطفى علي" userId="c6ea1ee86786e35d" providerId="LiveId" clId="{471EB1E5-A5B5-4169-BAFF-97E1977EEA39}" dt="2026-08-25T01:36:52.907" v="51"/>
+      <pc:chgData name="محمد رضا مصطفى علي" userId="c6ea1ee86786e35d" providerId="LiveId" clId="{471EB1E5-A5B5-4169-BAFF-97E1977EEA39}" dt="2026-08-26T23:51:52.466" v="76" actId="1076"/>
       <pc:docMkLst>
         <pc:docMk/>
       </pc:docMkLst>
@@ -316,20 +316,52 @@
           </ac:spMkLst>
         </pc:spChg>
       </pc:sldChg>
-      <pc:sldChg chg="modSp mod modTransition">
-        <pc:chgData name="محمد رضا مصطفى علي" userId="c6ea1ee86786e35d" providerId="LiveId" clId="{471EB1E5-A5B5-4169-BAFF-97E1977EEA39}" dt="2026-08-25T01:36:52.907" v="51"/>
+      <pc:sldChg chg="addSp delSp modSp mod modTransition">
+        <pc:chgData name="محمد رضا مصطفى علي" userId="c6ea1ee86786e35d" providerId="LiveId" clId="{471EB1E5-A5B5-4169-BAFF-97E1977EEA39}" dt="2026-08-26T23:51:52.466" v="76" actId="1076"/>
         <pc:sldMkLst>
           <pc:docMk/>
           <pc:sldMk cId="0" sldId="276"/>
         </pc:sldMkLst>
         <pc:spChg chg="mod">
-          <ac:chgData name="محمد رضا مصطفى علي" userId="c6ea1ee86786e35d" providerId="LiveId" clId="{471EB1E5-A5B5-4169-BAFF-97E1977EEA39}" dt="2026-08-25T01:31:45.441" v="13" actId="207"/>
+          <ac:chgData name="محمد رضا مصطفى علي" userId="c6ea1ee86786e35d" providerId="LiveId" clId="{471EB1E5-A5B5-4169-BAFF-97E1977EEA39}" dt="2026-08-26T23:51:13.594" v="67" actId="1076"/>
           <ac:spMkLst>
             <pc:docMk/>
             <pc:sldMk cId="0" sldId="276"/>
             <ac:spMk id="2" creationId="{00000000-0000-0000-0000-000000000000}"/>
           </ac:spMkLst>
         </pc:spChg>
+        <pc:spChg chg="add del mod">
+          <ac:chgData name="محمد رضا مصطفى علي" userId="c6ea1ee86786e35d" providerId="LiveId" clId="{471EB1E5-A5B5-4169-BAFF-97E1977EEA39}" dt="2026-08-26T23:51:16.603" v="70"/>
+          <ac:spMkLst>
+            <pc:docMk/>
+            <pc:sldMk cId="0" sldId="276"/>
+            <ac:spMk id="9" creationId="{EA5D2917-9E27-1B33-2BB5-40E34ADBA12F}"/>
+          </ac:spMkLst>
+        </pc:spChg>
+        <pc:spChg chg="add mod">
+          <ac:chgData name="محمد رضا مصطفى علي" userId="c6ea1ee86786e35d" providerId="LiveId" clId="{471EB1E5-A5B5-4169-BAFF-97E1977EEA39}" dt="2026-08-26T23:51:52.466" v="76" actId="1076"/>
+          <ac:spMkLst>
+            <pc:docMk/>
+            <pc:sldMk cId="0" sldId="276"/>
+            <ac:spMk id="10" creationId="{DE78C1BE-8D7F-9CBE-3850-E55228E8B55A}"/>
+          </ac:spMkLst>
+        </pc:spChg>
+        <pc:picChg chg="add mod">
+          <ac:chgData name="محمد رضا مصطفى علي" userId="c6ea1ee86786e35d" providerId="LiveId" clId="{471EB1E5-A5B5-4169-BAFF-97E1977EEA39}" dt="2026-08-26T23:51:47.058" v="75" actId="1076"/>
+          <ac:picMkLst>
+            <pc:docMk/>
+            <pc:sldMk cId="0" sldId="276"/>
+            <ac:picMk id="4" creationId="{A02EFB75-B9DB-7A1C-1A98-41C6DA2EE079}"/>
+          </ac:picMkLst>
+        </pc:picChg>
+        <pc:cxnChg chg="add mod">
+          <ac:chgData name="محمد رضا مصطفى علي" userId="c6ea1ee86786e35d" providerId="LiveId" clId="{471EB1E5-A5B5-4169-BAFF-97E1977EEA39}" dt="2026-08-26T23:51:09.089" v="66" actId="1076"/>
+          <ac:cxnSpMkLst>
+            <pc:docMk/>
+            <pc:sldMk cId="0" sldId="276"/>
+            <ac:cxnSpMk id="6" creationId="{0C785CD7-AE2F-8A66-BD0B-DF22B86B016B}"/>
+          </ac:cxnSpMkLst>
+        </pc:cxnChg>
       </pc:sldChg>
     </pc:docChg>
   </pc:docChgLst>
@@ -515,7 +547,7 @@
           <a:p>
             <a:fld id="{5BCAD085-E8A6-8845-BD4E-CB4CCA059FC4}" type="datetimeFigureOut">
               <a:rPr lang="en-US" smtClean="0"/>
-              <a:t>8/25/2026</a:t>
+              <a:t>8/27/2026</a:t>
             </a:fld>
             <a:endParaRPr lang="en-US"/>
           </a:p>
@@ -683,7 +715,7 @@
           <a:p>
             <a:fld id="{5BCAD085-E8A6-8845-BD4E-CB4CCA059FC4}" type="datetimeFigureOut">
               <a:rPr lang="en-US" smtClean="0"/>
-              <a:t>8/25/2026</a:t>
+              <a:t>8/27/2026</a:t>
             </a:fld>
             <a:endParaRPr lang="en-US"/>
           </a:p>
@@ -861,7 +893,7 @@
           <a:p>
             <a:fld id="{5BCAD085-E8A6-8845-BD4E-CB4CCA059FC4}" type="datetimeFigureOut">
               <a:rPr lang="en-US" smtClean="0"/>
-              <a:t>8/25/2026</a:t>
+              <a:t>8/27/2026</a:t>
             </a:fld>
             <a:endParaRPr lang="en-US"/>
           </a:p>
@@ -1029,7 +1061,7 @@
           <a:p>
             <a:fld id="{5BCAD085-E8A6-8845-BD4E-CB4CCA059FC4}" type="datetimeFigureOut">
               <a:rPr lang="en-US" smtClean="0"/>
-              <a:t>8/25/2026</a:t>
+              <a:t>8/27/2026</a:t>
             </a:fld>
             <a:endParaRPr lang="en-US"/>
           </a:p>
@@ -1274,7 +1306,7 @@
           <a:p>
             <a:fld id="{5BCAD085-E8A6-8845-BD4E-CB4CCA059FC4}" type="datetimeFigureOut">
               <a:rPr lang="en-US" smtClean="0"/>
-              <a:t>8/25/2026</a:t>
+              <a:t>8/27/2026</a:t>
             </a:fld>
             <a:endParaRPr lang="en-US"/>
           </a:p>
@@ -1559,7 +1591,7 @@
           <a:p>
             <a:fld id="{5BCAD085-E8A6-8845-BD4E-CB4CCA059FC4}" type="datetimeFigureOut">
               <a:rPr lang="en-US" smtClean="0"/>
-              <a:t>8/25/2026</a:t>
+              <a:t>8/27/2026</a:t>
             </a:fld>
             <a:endParaRPr lang="en-US"/>
           </a:p>
@@ -1978,7 +2010,7 @@
           <a:p>
             <a:fld id="{5BCAD085-E8A6-8845-BD4E-CB4CCA059FC4}" type="datetimeFigureOut">
               <a:rPr lang="en-US" smtClean="0"/>
-              <a:t>8/25/2026</a:t>
+              <a:t>8/27/2026</a:t>
             </a:fld>
             <a:endParaRPr lang="en-US"/>
           </a:p>
@@ -2095,7 +2127,7 @@
           <a:p>
             <a:fld id="{5BCAD085-E8A6-8845-BD4E-CB4CCA059FC4}" type="datetimeFigureOut">
               <a:rPr lang="en-US" smtClean="0"/>
-              <a:t>8/25/2026</a:t>
+              <a:t>8/27/2026</a:t>
             </a:fld>
             <a:endParaRPr lang="en-US"/>
           </a:p>
@@ -2190,7 +2222,7 @@
           <a:p>
             <a:fld id="{5BCAD085-E8A6-8845-BD4E-CB4CCA059FC4}" type="datetimeFigureOut">
               <a:rPr lang="en-US" smtClean="0"/>
-              <a:t>8/25/2026</a:t>
+              <a:t>8/27/2026</a:t>
             </a:fld>
             <a:endParaRPr lang="en-US"/>
           </a:p>
@@ -2465,7 +2497,7 @@
           <a:p>
             <a:fld id="{5BCAD085-E8A6-8845-BD4E-CB4CCA059FC4}" type="datetimeFigureOut">
               <a:rPr lang="en-US" smtClean="0"/>
-              <a:t>8/25/2026</a:t>
+              <a:t>8/27/2026</a:t>
             </a:fld>
             <a:endParaRPr lang="en-US"/>
           </a:p>
@@ -2717,7 +2749,7 @@
           <a:p>
             <a:fld id="{5BCAD085-E8A6-8845-BD4E-CB4CCA059FC4}" type="datetimeFigureOut">
               <a:rPr lang="en-US" smtClean="0"/>
-              <a:t>8/25/2026</a:t>
+              <a:t>8/27/2026</a:t>
             </a:fld>
             <a:endParaRPr lang="en-US"/>
           </a:p>
@@ -2928,7 +2960,7 @@
           <a:p>
             <a:fld id="{5BCAD085-E8A6-8845-BD4E-CB4CCA059FC4}" type="datetimeFigureOut">
               <a:rPr lang="en-US" smtClean="0"/>
-              <a:t>8/25/2026</a:t>
+              <a:t>8/27/2026</a:t>
             </a:fld>
             <a:endParaRPr lang="en-US"/>
           </a:p>
@@ -3380,13 +3412,13 @@
   <p:clrMapOvr>
     <a:masterClrMapping/>
   </p:clrMapOvr>
-  <mc:AlternateContent xmlns:mc="http://schemas.openxmlformats.org/markup-compatibility/2006">
-    <mc:Choice xmlns:p14="http://schemas.microsoft.com/office/powerpoint/2010/main" Requires="p14">
+  <mc:AlternateContent xmlns:mc="http://schemas.openxmlformats.org/markup-compatibility/2006" xmlns:p14="http://schemas.microsoft.com/office/powerpoint/2010/main">
+    <mc:Choice Requires="p14">
       <p:transition spd="slow" p14:dur="1500">
         <p:split orient="vert"/>
       </p:transition>
     </mc:Choice>
-    <mc:Fallback>
+    <mc:Fallback xmlns="">
       <p:transition spd="slow">
         <p:split orient="vert"/>
       </p:transition>
@@ -6529,7 +6561,7 @@
         </p:nvSpPr>
         <p:spPr>
           <a:xfrm>
-            <a:off x="2985435" y="2044005"/>
+            <a:off x="609601" y="2044005"/>
             <a:ext cx="6221130" cy="2769989"/>
           </a:xfrm>
           <a:prstGeom prst="rect">
@@ -6604,18 +6636,130 @@
           </a:p>
         </p:txBody>
       </p:sp>
+      <p:pic>
+        <p:nvPicPr>
+          <p:cNvPr id="4" name="Picture 3">
+            <a:extLst>
+              <a:ext uri="{FF2B5EF4-FFF2-40B4-BE49-F238E27FC236}">
+                <a16:creationId xmlns:a16="http://schemas.microsoft.com/office/drawing/2014/main" id="{A02EFB75-B9DB-7A1C-1A98-41C6DA2EE079}"/>
+              </a:ext>
+            </a:extLst>
+          </p:cNvPr>
+          <p:cNvPicPr>
+            <a:picLocks noChangeAspect="1"/>
+          </p:cNvPicPr>
+          <p:nvPr/>
+        </p:nvPicPr>
+        <p:blipFill>
+          <a:blip r:embed="rId2"/>
+          <a:stretch>
+            <a:fillRect/>
+          </a:stretch>
+        </p:blipFill>
+        <p:spPr>
+          <a:xfrm>
+            <a:off x="8553449" y="1469824"/>
+            <a:ext cx="2857500" cy="2857500"/>
+          </a:xfrm>
+          <a:prstGeom prst="rect">
+            <a:avLst/>
+          </a:prstGeom>
+        </p:spPr>
+      </p:pic>
+      <p:cxnSp>
+        <p:nvCxnSpPr>
+          <p:cNvPr id="6" name="Straight Connector 5">
+            <a:extLst>
+              <a:ext uri="{FF2B5EF4-FFF2-40B4-BE49-F238E27FC236}">
+                <a16:creationId xmlns:a16="http://schemas.microsoft.com/office/drawing/2014/main" id="{0C785CD7-AE2F-8A66-BD0B-DF22B86B016B}"/>
+              </a:ext>
+            </a:extLst>
+          </p:cNvPr>
+          <p:cNvCxnSpPr>
+            <a:cxnSpLocks/>
+          </p:cNvCxnSpPr>
+          <p:nvPr/>
+        </p:nvCxnSpPr>
+        <p:spPr>
+          <a:xfrm>
+            <a:off x="7572376" y="827781"/>
+            <a:ext cx="0" cy="5114925"/>
+          </a:xfrm>
+          <a:prstGeom prst="line">
+            <a:avLst/>
+          </a:prstGeom>
+          <a:ln>
+            <a:solidFill>
+              <a:srgbClr val="00B0F0"/>
+            </a:solidFill>
+          </a:ln>
+        </p:spPr>
+        <p:style>
+          <a:lnRef idx="3">
+            <a:schemeClr val="accent2"/>
+          </a:lnRef>
+          <a:fillRef idx="0">
+            <a:schemeClr val="accent2"/>
+          </a:fillRef>
+          <a:effectRef idx="2">
+            <a:schemeClr val="accent2"/>
+          </a:effectRef>
+          <a:fontRef idx="minor">
+            <a:schemeClr val="tx1"/>
+          </a:fontRef>
+        </p:style>
+      </p:cxnSp>
+      <p:sp>
+        <p:nvSpPr>
+          <p:cNvPr id="10" name="TextBox 9">
+            <a:extLst>
+              <a:ext uri="{FF2B5EF4-FFF2-40B4-BE49-F238E27FC236}">
+                <a16:creationId xmlns:a16="http://schemas.microsoft.com/office/drawing/2014/main" id="{DE78C1BE-8D7F-9CBE-3850-E55228E8B55A}"/>
+              </a:ext>
+            </a:extLst>
+          </p:cNvPr>
+          <p:cNvSpPr txBox="1"/>
+          <p:nvPr/>
+        </p:nvSpPr>
+        <p:spPr>
+          <a:xfrm>
+            <a:off x="8079787" y="4167663"/>
+            <a:ext cx="3804824" cy="646331"/>
+          </a:xfrm>
+          <a:prstGeom prst="rect">
+            <a:avLst/>
+          </a:prstGeom>
+          <a:noFill/>
+        </p:spPr>
+        <p:txBody>
+          <a:bodyPr wrap="none" rtlCol="0">
+            <a:spAutoFit/>
+          </a:bodyPr>
+          <a:lstStyle/>
+          <a:p>
+            <a:r>
+              <a:rPr lang="en-US" sz="3600" dirty="0">
+                <a:solidFill>
+                  <a:srgbClr val="00B0F0"/>
+                </a:solidFill>
+              </a:rPr>
+              <a:t>Scan to Try the App</a:t>
+            </a:r>
+          </a:p>
+        </p:txBody>
+      </p:sp>
     </p:spTree>
   </p:cSld>
   <p:clrMapOvr>
     <a:masterClrMapping/>
   </p:clrMapOvr>
-  <mc:AlternateContent xmlns:mc="http://schemas.openxmlformats.org/markup-compatibility/2006">
-    <mc:Choice xmlns:p14="http://schemas.microsoft.com/office/powerpoint/2010/main" Requires="p14">
+  <mc:AlternateContent xmlns:mc="http://schemas.openxmlformats.org/markup-compatibility/2006" xmlns:p14="http://schemas.microsoft.com/office/powerpoint/2010/main">
+    <mc:Choice Requires="p14">
       <p:transition spd="slow" p14:dur="800">
         <p:circle/>
       </p:transition>
     </mc:Choice>
-    <mc:Fallback>
+    <mc:Fallback xmlns="">
       <p:transition spd="slow">
         <p:circle/>
       </p:transition>

</xml_diff>